<commit_message>
Week 1 Day 2: Python Programming Fundamentals I and II
</commit_message>
<xml_diff>
--- a/week_01/Day 2/Python Programming Fundamentals II.pptx
+++ b/week_01/Day 2/Python Programming Fundamentals II.pptx
@@ -18,9 +18,9 @@
     <p:sldId id="286" r:id="rId9"/>
     <p:sldId id="283" r:id="rId10"/>
     <p:sldId id="260" r:id="rId11"/>
-    <p:sldId id="287" r:id="rId12"/>
-    <p:sldId id="288" r:id="rId13"/>
-    <p:sldId id="289" r:id="rId14"/>
+    <p:sldId id="288" r:id="rId12"/>
+    <p:sldId id="289" r:id="rId13"/>
+    <p:sldId id="287" r:id="rId14"/>
   </p:sldIdLst>
   <p:sldSz cx="12192000" cy="6858000"/>
   <p:notesSz cx="6858000" cy="9144000"/>
@@ -126,6 +126,7 @@
 <p1510:revInfo xmlns:a="http://schemas.openxmlformats.org/drawingml/2006/main" xmlns:r="http://schemas.openxmlformats.org/officeDocument/2006/relationships" xmlns:p1510="http://schemas.microsoft.com/office/powerpoint/2015/10/main">
   <p1510:revLst>
     <p1510:client id="{93E427CF-E2FC-4793-7C29-E5BC33932AEF}" v="111" dt="2026-02-12T09:05:33.121"/>
+    <p1510:client id="{A309FDD5-CA39-16E1-2D5B-FCF0232602A8}" v="1" dt="2026-02-13T21:08:14.570"/>
   </p1510:revLst>
 </p1510:revInfo>
 </file>
@@ -218,6 +219,22 @@
         <pc:sldMkLst>
           <pc:docMk/>
           <pc:sldMk cId="838455973" sldId="282"/>
+        </pc:sldMkLst>
+      </pc:sldChg>
+    </pc:docChg>
+  </pc:docChgLst>
+  <pc:docChgLst>
+    <pc:chgData name="Olawale Abiodun Ogundeji (Dr.)" userId="S::wale@ahfid.org::bf7f3b58-5492-4b16-a9d7-34d40e1eb056" providerId="AD" clId="Web-{A309FDD5-CA39-16E1-2D5B-FCF0232602A8}"/>
+    <pc:docChg chg="sldOrd">
+      <pc:chgData name="Olawale Abiodun Ogundeji (Dr.)" userId="S::wale@ahfid.org::bf7f3b58-5492-4b16-a9d7-34d40e1eb056" providerId="AD" clId="Web-{A309FDD5-CA39-16E1-2D5B-FCF0232602A8}" dt="2026-02-13T21:08:14.570" v="0"/>
+      <pc:docMkLst>
+        <pc:docMk/>
+      </pc:docMkLst>
+      <pc:sldChg chg="ord">
+        <pc:chgData name="Olawale Abiodun Ogundeji (Dr.)" userId="S::wale@ahfid.org::bf7f3b58-5492-4b16-a9d7-34d40e1eb056" providerId="AD" clId="Web-{A309FDD5-CA39-16E1-2D5B-FCF0232602A8}" dt="2026-02-13T21:08:14.570" v="0"/>
+        <pc:sldMkLst>
+          <pc:docMk/>
+          <pc:sldMk cId="2208187676" sldId="287"/>
         </pc:sldMkLst>
       </pc:sldChg>
     </pc:docChg>
@@ -455,36 +472,12 @@
           <pc:docMk/>
           <pc:sldMk cId="0" sldId="259"/>
         </pc:sldMkLst>
-        <pc:spChg chg="del">
-          <ac:chgData name="Olawale Abiodun Ogundeji (Dr.)" userId="S::wale@ahfid.org::bf7f3b58-5492-4b16-a9d7-34d40e1eb056" providerId="AD" clId="Web-{93E427CF-E2FC-4793-7C29-E5BC33932AEF}" dt="2026-02-11T15:12:57.771" v="7"/>
-          <ac:spMkLst>
-            <pc:docMk/>
-            <pc:sldMk cId="0" sldId="259"/>
-            <ac:spMk id="3" creationId="{3EDAD1F7-BB38-C95D-7ECE-AAB912129DEF}"/>
-          </ac:spMkLst>
-        </pc:spChg>
-        <pc:spChg chg="del">
-          <ac:chgData name="Olawale Abiodun Ogundeji (Dr.)" userId="S::wale@ahfid.org::bf7f3b58-5492-4b16-a9d7-34d40e1eb056" providerId="AD" clId="Web-{93E427CF-E2FC-4793-7C29-E5BC33932AEF}" dt="2026-02-11T15:12:52.130" v="5"/>
-          <ac:spMkLst>
-            <pc:docMk/>
-            <pc:sldMk cId="0" sldId="259"/>
-            <ac:spMk id="6" creationId="{3D51C889-42B9-2081-B278-7B11140FAFD7}"/>
-          </ac:spMkLst>
-        </pc:spChg>
         <pc:picChg chg="add mod">
           <ac:chgData name="Olawale Abiodun Ogundeji (Dr.)" userId="S::wale@ahfid.org::bf7f3b58-5492-4b16-a9d7-34d40e1eb056" providerId="AD" clId="Web-{93E427CF-E2FC-4793-7C29-E5BC33932AEF}" dt="2026-02-11T15:13:31.521" v="15" actId="1076"/>
           <ac:picMkLst>
             <pc:docMk/>
             <pc:sldMk cId="0" sldId="259"/>
             <ac:picMk id="4" creationId="{04FA8372-E0CC-18F3-4709-07909AA89B6E}"/>
-          </ac:picMkLst>
-        </pc:picChg>
-        <pc:picChg chg="del">
-          <ac:chgData name="Olawale Abiodun Ogundeji (Dr.)" userId="S::wale@ahfid.org::bf7f3b58-5492-4b16-a9d7-34d40e1eb056" providerId="AD" clId="Web-{93E427CF-E2FC-4793-7C29-E5BC33932AEF}" dt="2026-02-11T15:12:54.162" v="6"/>
-          <ac:picMkLst>
-            <pc:docMk/>
-            <pc:sldMk cId="0" sldId="259"/>
-            <ac:picMk id="5" creationId="{8A7E6FBF-183A-FD2A-276E-6B16E36D87B4}"/>
           </ac:picMkLst>
         </pc:picChg>
       </pc:sldChg>
@@ -525,30 +518,6 @@
           <pc:docMk/>
           <pc:sldMk cId="316734042" sldId="279"/>
         </pc:sldMkLst>
-        <pc:spChg chg="del">
-          <ac:chgData name="Olawale Abiodun Ogundeji (Dr.)" userId="S::wale@ahfid.org::bf7f3b58-5492-4b16-a9d7-34d40e1eb056" providerId="AD" clId="Web-{93E427CF-E2FC-4793-7C29-E5BC33932AEF}" dt="2026-02-11T15:19:55.780" v="36"/>
-          <ac:spMkLst>
-            <pc:docMk/>
-            <pc:sldMk cId="316734042" sldId="279"/>
-            <ac:spMk id="3" creationId="{CE12020B-B16B-503A-3FCF-44BFBD11530F}"/>
-          </ac:spMkLst>
-        </pc:spChg>
-        <pc:spChg chg="del">
-          <ac:chgData name="Olawale Abiodun Ogundeji (Dr.)" userId="S::wale@ahfid.org::bf7f3b58-5492-4b16-a9d7-34d40e1eb056" providerId="AD" clId="Web-{93E427CF-E2FC-4793-7C29-E5BC33932AEF}" dt="2026-02-11T15:19:49.545" v="35"/>
-          <ac:spMkLst>
-            <pc:docMk/>
-            <pc:sldMk cId="316734042" sldId="279"/>
-            <ac:spMk id="5" creationId="{77105D8D-AE67-7EF3-2996-3921B2E4A175}"/>
-          </ac:spMkLst>
-        </pc:spChg>
-        <pc:picChg chg="add del mod">
-          <ac:chgData name="Olawale Abiodun Ogundeji (Dr.)" userId="S::wale@ahfid.org::bf7f3b58-5492-4b16-a9d7-34d40e1eb056" providerId="AD" clId="Web-{93E427CF-E2FC-4793-7C29-E5BC33932AEF}" dt="2026-02-11T15:22:28.410" v="42"/>
-          <ac:picMkLst>
-            <pc:docMk/>
-            <pc:sldMk cId="316734042" sldId="279"/>
-            <ac:picMk id="4" creationId="{1B85B1EE-0D12-6A42-6C4D-3EDF06CE63BE}"/>
-          </ac:picMkLst>
-        </pc:picChg>
         <pc:picChg chg="add mod">
           <ac:chgData name="Olawale Abiodun Ogundeji (Dr.)" userId="S::wale@ahfid.org::bf7f3b58-5492-4b16-a9d7-34d40e1eb056" providerId="AD" clId="Web-{93E427CF-E2FC-4793-7C29-E5BC33932AEF}" dt="2026-02-11T15:22:34.910" v="45" actId="1076"/>
           <ac:picMkLst>
@@ -571,30 +540,6 @@
           <pc:docMk/>
           <pc:sldMk cId="4279679797" sldId="281"/>
         </pc:sldMkLst>
-        <pc:spChg chg="del">
-          <ac:chgData name="Olawale Abiodun Ogundeji (Dr.)" userId="S::wale@ahfid.org::bf7f3b58-5492-4b16-a9d7-34d40e1eb056" providerId="AD" clId="Web-{93E427CF-E2FC-4793-7C29-E5BC33932AEF}" dt="2026-02-11T15:15:35.200" v="27"/>
-          <ac:spMkLst>
-            <pc:docMk/>
-            <pc:sldMk cId="4279679797" sldId="281"/>
-            <ac:spMk id="3" creationId="{29EA01AE-3CB5-B85C-4F90-0AA98E7E85D4}"/>
-          </ac:spMkLst>
-        </pc:spChg>
-        <pc:spChg chg="del">
-          <ac:chgData name="Olawale Abiodun Ogundeji (Dr.)" userId="S::wale@ahfid.org::bf7f3b58-5492-4b16-a9d7-34d40e1eb056" providerId="AD" clId="Web-{93E427CF-E2FC-4793-7C29-E5BC33932AEF}" dt="2026-02-11T15:15:31.637" v="26"/>
-          <ac:spMkLst>
-            <pc:docMk/>
-            <pc:sldMk cId="4279679797" sldId="281"/>
-            <ac:spMk id="6" creationId="{63718E18-FF39-BA2D-9E5A-EF0B31471753}"/>
-          </ac:spMkLst>
-        </pc:spChg>
-        <pc:picChg chg="del">
-          <ac:chgData name="Olawale Abiodun Ogundeji (Dr.)" userId="S::wale@ahfid.org::bf7f3b58-5492-4b16-a9d7-34d40e1eb056" providerId="AD" clId="Web-{93E427CF-E2FC-4793-7C29-E5BC33932AEF}" dt="2026-02-11T15:15:28.840" v="25"/>
-          <ac:picMkLst>
-            <pc:docMk/>
-            <pc:sldMk cId="4279679797" sldId="281"/>
-            <ac:picMk id="4" creationId="{E67E3322-C0AF-1BB1-C14C-DBBBC5EC5973}"/>
-          </ac:picMkLst>
-        </pc:picChg>
         <pc:picChg chg="add mod">
           <ac:chgData name="Olawale Abiodun Ogundeji (Dr.)" userId="S::wale@ahfid.org::bf7f3b58-5492-4b16-a9d7-34d40e1eb056" providerId="AD" clId="Web-{93E427CF-E2FC-4793-7C29-E5BC33932AEF}" dt="2026-02-11T15:16:07.359" v="33" actId="14100"/>
           <ac:picMkLst>
@@ -610,22 +555,6 @@
           <pc:docMk/>
           <pc:sldMk cId="838455973" sldId="282"/>
         </pc:sldMkLst>
-        <pc:spChg chg="del">
-          <ac:chgData name="Olawale Abiodun Ogundeji (Dr.)" userId="S::wale@ahfid.org::bf7f3b58-5492-4b16-a9d7-34d40e1eb056" providerId="AD" clId="Web-{93E427CF-E2FC-4793-7C29-E5BC33932AEF}" dt="2026-02-11T15:13:52.990" v="17"/>
-          <ac:spMkLst>
-            <pc:docMk/>
-            <pc:sldMk cId="838455973" sldId="282"/>
-            <ac:spMk id="2" creationId="{AC8F6D7D-7528-C26E-EA85-8A59B1AE2E8C}"/>
-          </ac:spMkLst>
-        </pc:spChg>
-        <pc:spChg chg="del">
-          <ac:chgData name="Olawale Abiodun Ogundeji (Dr.)" userId="S::wale@ahfid.org::bf7f3b58-5492-4b16-a9d7-34d40e1eb056" providerId="AD" clId="Web-{93E427CF-E2FC-4793-7C29-E5BC33932AEF}" dt="2026-02-11T15:13:56.475" v="18"/>
-          <ac:spMkLst>
-            <pc:docMk/>
-            <pc:sldMk cId="838455973" sldId="282"/>
-            <ac:spMk id="3" creationId="{BC0CCE73-69DE-DA43-60A1-1B82A308C880}"/>
-          </ac:spMkLst>
-        </pc:spChg>
         <pc:picChg chg="add mod">
           <ac:chgData name="Olawale Abiodun Ogundeji (Dr.)" userId="S::wale@ahfid.org::bf7f3b58-5492-4b16-a9d7-34d40e1eb056" providerId="AD" clId="Web-{93E427CF-E2FC-4793-7C29-E5BC33932AEF}" dt="2026-02-11T15:14:50.508" v="23" actId="14100"/>
           <ac:picMkLst>
@@ -899,7 +828,7 @@
           </a:lstStyle>
           <a:p>
             <a:fld id="{F29A7199-659A-4064-9D87-9E89ED46822F}" type="datetimeFigureOut">
-              <a:t>2/12/2026</a:t>
+              <a:t>2/13/2026</a:t>
             </a:fld>
             <a:endParaRPr lang="en-GB"/>
           </a:p>
@@ -4392,7 +4321,7 @@
             <a:pPr algn="l"/>
             <a:fld id="{A5B0A250-5CC0-1746-B209-08E8B0DAE6AF}" type="datetimeFigureOut">
               <a:rPr lang="en-US" smtClean="0"/>
-              <a:t>2/12/2026</a:t>
+              <a:t>2/13/2026</a:t>
             </a:fld>
             <a:endParaRPr lang="en-US"/>
           </a:p>
@@ -5757,7 +5686,7 @@
           <a:p>
             <a:fld id="{A5B0A250-5CC0-1746-B209-08E8B0DAE6AF}" type="datetimeFigureOut">
               <a:rPr lang="en-US" smtClean="0"/>
-              <a:t>2/12/2026</a:t>
+              <a:t>2/13/2026</a:t>
             </a:fld>
             <a:endParaRPr lang="en-US"/>
           </a:p>
@@ -6601,7 +6530,7 @@
           <a:p>
             <a:fld id="{A5B0A250-5CC0-1746-B209-08E8B0DAE6AF}" type="datetimeFigureOut">
               <a:rPr lang="en-US" smtClean="0"/>
-              <a:t>2/12/2026</a:t>
+              <a:t>2/13/2026</a:t>
             </a:fld>
             <a:endParaRPr lang="en-US"/>
           </a:p>
@@ -6801,7 +6730,7 @@
           <a:p>
             <a:fld id="{A5B0A250-5CC0-1746-B209-08E8B0DAE6AF}" type="datetimeFigureOut">
               <a:rPr lang="en-US" smtClean="0"/>
-              <a:t>2/12/2026</a:t>
+              <a:t>2/13/2026</a:t>
             </a:fld>
             <a:endParaRPr lang="en-US"/>
           </a:p>
@@ -7107,7 +7036,7 @@
           <a:p>
             <a:fld id="{A5B0A250-5CC0-1746-B209-08E8B0DAE6AF}" type="datetimeFigureOut">
               <a:rPr lang="en-US" smtClean="0"/>
-              <a:t>2/12/2026</a:t>
+              <a:t>2/13/2026</a:t>
             </a:fld>
             <a:endParaRPr lang="en-US"/>
           </a:p>
@@ -9958,7 +9887,7 @@
           <a:p>
             <a:fld id="{A5B0A250-5CC0-1746-B209-08E8B0DAE6AF}" type="datetimeFigureOut">
               <a:rPr lang="en-US" smtClean="0"/>
-              <a:t>2/12/2026</a:t>
+              <a:t>2/13/2026</a:t>
             </a:fld>
             <a:endParaRPr lang="en-US"/>
           </a:p>
@@ -11091,7 +11020,7 @@
           <a:p>
             <a:fld id="{A5B0A250-5CC0-1746-B209-08E8B0DAE6AF}" type="datetimeFigureOut">
               <a:rPr lang="en-US" smtClean="0"/>
-              <a:t>2/12/2026</a:t>
+              <a:t>2/13/2026</a:t>
             </a:fld>
             <a:endParaRPr lang="en-US"/>
           </a:p>
@@ -11945,7 +11874,7 @@
           <a:p>
             <a:fld id="{A5B0A250-5CC0-1746-B209-08E8B0DAE6AF}" type="datetimeFigureOut">
               <a:rPr lang="en-US" smtClean="0"/>
-              <a:t>2/12/2026</a:t>
+              <a:t>2/13/2026</a:t>
             </a:fld>
             <a:endParaRPr lang="en-US"/>
           </a:p>
@@ -12102,7 +12031,7 @@
           <a:p>
             <a:fld id="{A5B0A250-5CC0-1746-B209-08E8B0DAE6AF}" type="datetimeFigureOut">
               <a:rPr lang="en-US" smtClean="0"/>
-              <a:t>2/12/2026</a:t>
+              <a:t>2/13/2026</a:t>
             </a:fld>
             <a:endParaRPr lang="en-US"/>
           </a:p>
@@ -13031,7 +12960,7 @@
           <a:p>
             <a:fld id="{A5B0A250-5CC0-1746-B209-08E8B0DAE6AF}" type="datetimeFigureOut">
               <a:rPr lang="en-US" smtClean="0"/>
-              <a:t>2/12/2026</a:t>
+              <a:t>2/13/2026</a:t>
             </a:fld>
             <a:endParaRPr lang="en-US"/>
           </a:p>
@@ -13996,7 +13925,7 @@
           <a:p>
             <a:fld id="{A5B0A250-5CC0-1746-B209-08E8B0DAE6AF}" type="datetimeFigureOut">
               <a:rPr lang="en-US" smtClean="0"/>
-              <a:t>2/12/2026</a:t>
+              <a:t>2/13/2026</a:t>
             </a:fld>
             <a:endParaRPr lang="en-US"/>
           </a:p>
@@ -14240,7 +14169,7 @@
           <a:p>
             <a:fld id="{A5B0A250-5CC0-1746-B209-08E8B0DAE6AF}" type="datetimeFigureOut">
               <a:rPr lang="en-US" smtClean="0"/>
-              <a:t>2/12/2026</a:t>
+              <a:t>2/13/2026</a:t>
             </a:fld>
             <a:endParaRPr lang="en-US"/>
           </a:p>
@@ -14872,193 +14801,6 @@
         <p:cNvPr id="1" name="">
           <a:extLst>
             <a:ext uri="{FF2B5EF4-FFF2-40B4-BE49-F238E27FC236}">
-              <a16:creationId xmlns:a16="http://schemas.microsoft.com/office/drawing/2014/main" id="{855C92BF-C130-EED2-354C-1633DD82E216}"/>
-            </a:ext>
-          </a:extLst>
-        </p:cNvPr>
-        <p:cNvGrpSpPr/>
-        <p:nvPr/>
-      </p:nvGrpSpPr>
-      <p:grpSpPr>
-        <a:xfrm>
-          <a:off x="0" y="0"/>
-          <a:ext cx="0" cy="0"/>
-          <a:chOff x="0" y="0"/>
-          <a:chExt cx="0" cy="0"/>
-        </a:xfrm>
-      </p:grpSpPr>
-      <p:sp>
-        <p:nvSpPr>
-          <p:cNvPr id="7" name="Title 1">
-            <a:extLst>
-              <a:ext uri="{FF2B5EF4-FFF2-40B4-BE49-F238E27FC236}">
-                <a16:creationId xmlns:a16="http://schemas.microsoft.com/office/drawing/2014/main" id="{85BB4AE4-4ADB-D8A6-DEEB-45944669D89F}"/>
-              </a:ext>
-            </a:extLst>
-          </p:cNvPr>
-          <p:cNvSpPr txBox="1"/>
-          <p:nvPr/>
-        </p:nvSpPr>
-        <p:spPr>
-          <a:xfrm>
-            <a:off x="1096092" y="1474086"/>
-            <a:ext cx="8420049" cy="391606"/>
-          </a:xfrm>
-          <a:prstGeom prst="rect">
-            <a:avLst/>
-          </a:prstGeom>
-        </p:spPr>
-        <p:txBody>
-          <a:bodyPr vert="horz" lIns="91440" tIns="45720" rIns="91440" bIns="45720" rtlCol="0" anchor="t">
-            <a:noAutofit/>
-          </a:bodyPr>
-          <a:lstStyle>
-            <a:lvl1pPr algn="l" defTabSz="914400" rtl="0" eaLnBrk="1" latinLnBrk="0" hangingPunct="1">
-              <a:lnSpc>
-                <a:spcPct val="100000"/>
-              </a:lnSpc>
-              <a:spcBef>
-                <a:spcPct val="0"/>
-              </a:spcBef>
-              <a:buNone/>
-              <a:defRPr sz="4000" b="1" i="0" kern="1200">
-                <a:solidFill>
-                  <a:schemeClr val="tx1"/>
-                </a:solidFill>
-                <a:latin typeface="+mj-lt"/>
-                <a:ea typeface="+mj-ea"/>
-                <a:cs typeface="+mj-cs"/>
-              </a:defRPr>
-            </a:lvl1pPr>
-          </a:lstStyle>
-          <a:p>
-            <a:endParaRPr lang="en-GB" sz="2000">
-              <a:latin typeface="Arial" panose="020B0604020202020204" pitchFamily="34" charset="0"/>
-              <a:cs typeface="Arial" panose="020B0604020202020204" pitchFamily="34" charset="0"/>
-            </a:endParaRPr>
-          </a:p>
-        </p:txBody>
-      </p:sp>
-      <p:sp>
-        <p:nvSpPr>
-          <p:cNvPr id="8" name="Title 1">
-            <a:extLst>
-              <a:ext uri="{FF2B5EF4-FFF2-40B4-BE49-F238E27FC236}">
-                <a16:creationId xmlns:a16="http://schemas.microsoft.com/office/drawing/2014/main" id="{99DB2A01-6CF8-F06A-6B9C-C685096E3E0C}"/>
-              </a:ext>
-            </a:extLst>
-          </p:cNvPr>
-          <p:cNvSpPr txBox="1"/>
-          <p:nvPr/>
-        </p:nvSpPr>
-        <p:spPr>
-          <a:xfrm>
-            <a:off x="1096092" y="1928724"/>
-            <a:ext cx="6888960" cy="3345597"/>
-          </a:xfrm>
-          <a:prstGeom prst="rect">
-            <a:avLst/>
-          </a:prstGeom>
-        </p:spPr>
-        <p:txBody>
-          <a:bodyPr vert="horz" lIns="91440" tIns="45720" rIns="91440" bIns="45720" rtlCol="0" anchor="t">
-            <a:noAutofit/>
-          </a:bodyPr>
-          <a:lstStyle>
-            <a:lvl1pPr algn="l" defTabSz="914400" rtl="0" eaLnBrk="1" latinLnBrk="0" hangingPunct="1">
-              <a:lnSpc>
-                <a:spcPct val="100000"/>
-              </a:lnSpc>
-              <a:spcBef>
-                <a:spcPct val="0"/>
-              </a:spcBef>
-              <a:buNone/>
-              <a:defRPr sz="4000" b="1" i="0" kern="1200">
-                <a:solidFill>
-                  <a:schemeClr val="tx1"/>
-                </a:solidFill>
-                <a:latin typeface="+mj-lt"/>
-                <a:ea typeface="+mj-ea"/>
-                <a:cs typeface="+mj-cs"/>
-              </a:defRPr>
-            </a:lvl1pPr>
-          </a:lstStyle>
-          <a:p>
-            <a:pPr marL="514350" indent="-514350">
-              <a:lnSpc>
-                <a:spcPct val="150000"/>
-              </a:lnSpc>
-              <a:buFont typeface="+mj-lt"/>
-              <a:buAutoNum type="arabicPeriod"/>
-            </a:pPr>
-            <a:endParaRPr lang="en-GB" sz="1600" b="0">
-              <a:latin typeface="Arial" panose="020B0604020202020204" pitchFamily="34" charset="0"/>
-              <a:cs typeface="Arial" panose="020B0604020202020204" pitchFamily="34" charset="0"/>
-            </a:endParaRPr>
-          </a:p>
-        </p:txBody>
-      </p:sp>
-      <p:pic>
-        <p:nvPicPr>
-          <p:cNvPr id="4" name="Picture 3" descr="A screenshot of a computer program&#10;&#10;AI-generated content may be incorrect.">
-            <a:extLst>
-              <a:ext uri="{FF2B5EF4-FFF2-40B4-BE49-F238E27FC236}">
-                <a16:creationId xmlns:a16="http://schemas.microsoft.com/office/drawing/2014/main" id="{0B602ED8-5D82-553A-0485-1C14AE24A1A7}"/>
-              </a:ext>
-            </a:extLst>
-          </p:cNvPr>
-          <p:cNvPicPr>
-            <a:picLocks noChangeAspect="1"/>
-          </p:cNvPicPr>
-          <p:nvPr/>
-        </p:nvPicPr>
-        <p:blipFill>
-          <a:blip r:embed="rId2"/>
-          <a:stretch>
-            <a:fillRect/>
-          </a:stretch>
-        </p:blipFill>
-        <p:spPr>
-          <a:xfrm>
-            <a:off x="2050382" y="1257551"/>
-            <a:ext cx="8422106" cy="4683793"/>
-          </a:xfrm>
-          <a:prstGeom prst="rect">
-            <a:avLst/>
-          </a:prstGeom>
-        </p:spPr>
-      </p:pic>
-    </p:spTree>
-    <p:extLst>
-      <p:ext uri="{BB962C8B-B14F-4D97-AF65-F5344CB8AC3E}">
-        <p14:creationId xmlns:p14="http://schemas.microsoft.com/office/powerpoint/2010/main" val="2208187676"/>
-      </p:ext>
-    </p:extLst>
-  </p:cSld>
-  <p:clrMapOvr>
-    <a:masterClrMapping/>
-  </p:clrMapOvr>
-</p:sld>
-</file>
-
-<file path=ppt/slides/slide12.xml><?xml version="1.0" encoding="utf-8"?>
-<p:sld xmlns:a="http://schemas.openxmlformats.org/drawingml/2006/main" xmlns:r="http://schemas.openxmlformats.org/officeDocument/2006/relationships" xmlns:p="http://schemas.openxmlformats.org/presentationml/2006/main">
-  <p:cSld>
-    <p:bg>
-      <p:bgPr>
-        <a:solidFill>
-          <a:schemeClr val="accent3">
-            <a:lumMod val="75000"/>
-          </a:schemeClr>
-        </a:solidFill>
-        <a:effectLst/>
-      </p:bgPr>
-    </p:bg>
-    <p:spTree>
-      <p:nvGrpSpPr>
-        <p:cNvPr id="1" name="">
-          <a:extLst>
-            <a:ext uri="{FF2B5EF4-FFF2-40B4-BE49-F238E27FC236}">
               <a16:creationId xmlns:a16="http://schemas.microsoft.com/office/drawing/2014/main" id="{DEF2923C-623F-885F-8E7F-B88E40E880D6}"/>
             </a:ext>
           </a:extLst>
@@ -15228,7 +14970,7 @@
 </p:sld>
 </file>
 
-<file path=ppt/slides/slide13.xml><?xml version="1.0" encoding="utf-8"?>
+<file path=ppt/slides/slide12.xml><?xml version="1.0" encoding="utf-8"?>
 <p:sld xmlns:a="http://schemas.openxmlformats.org/drawingml/2006/main" xmlns:r="http://schemas.openxmlformats.org/officeDocument/2006/relationships" xmlns:p="http://schemas.openxmlformats.org/presentationml/2006/main">
   <p:cSld>
     <p:bg>
@@ -15406,6 +15148,193 @@
     <p:extLst>
       <p:ext uri="{BB962C8B-B14F-4D97-AF65-F5344CB8AC3E}">
         <p14:creationId xmlns:p14="http://schemas.microsoft.com/office/powerpoint/2010/main" val="3766290384"/>
+      </p:ext>
+    </p:extLst>
+  </p:cSld>
+  <p:clrMapOvr>
+    <a:masterClrMapping/>
+  </p:clrMapOvr>
+</p:sld>
+</file>
+
+<file path=ppt/slides/slide13.xml><?xml version="1.0" encoding="utf-8"?>
+<p:sld xmlns:a="http://schemas.openxmlformats.org/drawingml/2006/main" xmlns:r="http://schemas.openxmlformats.org/officeDocument/2006/relationships" xmlns:p="http://schemas.openxmlformats.org/presentationml/2006/main">
+  <p:cSld>
+    <p:bg>
+      <p:bgPr>
+        <a:solidFill>
+          <a:schemeClr val="accent3">
+            <a:lumMod val="75000"/>
+          </a:schemeClr>
+        </a:solidFill>
+        <a:effectLst/>
+      </p:bgPr>
+    </p:bg>
+    <p:spTree>
+      <p:nvGrpSpPr>
+        <p:cNvPr id="1" name="">
+          <a:extLst>
+            <a:ext uri="{FF2B5EF4-FFF2-40B4-BE49-F238E27FC236}">
+              <a16:creationId xmlns:a16="http://schemas.microsoft.com/office/drawing/2014/main" id="{855C92BF-C130-EED2-354C-1633DD82E216}"/>
+            </a:ext>
+          </a:extLst>
+        </p:cNvPr>
+        <p:cNvGrpSpPr/>
+        <p:nvPr/>
+      </p:nvGrpSpPr>
+      <p:grpSpPr>
+        <a:xfrm>
+          <a:off x="0" y="0"/>
+          <a:ext cx="0" cy="0"/>
+          <a:chOff x="0" y="0"/>
+          <a:chExt cx="0" cy="0"/>
+        </a:xfrm>
+      </p:grpSpPr>
+      <p:sp>
+        <p:nvSpPr>
+          <p:cNvPr id="7" name="Title 1">
+            <a:extLst>
+              <a:ext uri="{FF2B5EF4-FFF2-40B4-BE49-F238E27FC236}">
+                <a16:creationId xmlns:a16="http://schemas.microsoft.com/office/drawing/2014/main" id="{85BB4AE4-4ADB-D8A6-DEEB-45944669D89F}"/>
+              </a:ext>
+            </a:extLst>
+          </p:cNvPr>
+          <p:cNvSpPr txBox="1"/>
+          <p:nvPr/>
+        </p:nvSpPr>
+        <p:spPr>
+          <a:xfrm>
+            <a:off x="1096092" y="1474086"/>
+            <a:ext cx="8420049" cy="391606"/>
+          </a:xfrm>
+          <a:prstGeom prst="rect">
+            <a:avLst/>
+          </a:prstGeom>
+        </p:spPr>
+        <p:txBody>
+          <a:bodyPr vert="horz" lIns="91440" tIns="45720" rIns="91440" bIns="45720" rtlCol="0" anchor="t">
+            <a:noAutofit/>
+          </a:bodyPr>
+          <a:lstStyle>
+            <a:lvl1pPr algn="l" defTabSz="914400" rtl="0" eaLnBrk="1" latinLnBrk="0" hangingPunct="1">
+              <a:lnSpc>
+                <a:spcPct val="100000"/>
+              </a:lnSpc>
+              <a:spcBef>
+                <a:spcPct val="0"/>
+              </a:spcBef>
+              <a:buNone/>
+              <a:defRPr sz="4000" b="1" i="0" kern="1200">
+                <a:solidFill>
+                  <a:schemeClr val="tx1"/>
+                </a:solidFill>
+                <a:latin typeface="+mj-lt"/>
+                <a:ea typeface="+mj-ea"/>
+                <a:cs typeface="+mj-cs"/>
+              </a:defRPr>
+            </a:lvl1pPr>
+          </a:lstStyle>
+          <a:p>
+            <a:endParaRPr lang="en-GB" sz="2000">
+              <a:latin typeface="Arial" panose="020B0604020202020204" pitchFamily="34" charset="0"/>
+              <a:cs typeface="Arial" panose="020B0604020202020204" pitchFamily="34" charset="0"/>
+            </a:endParaRPr>
+          </a:p>
+        </p:txBody>
+      </p:sp>
+      <p:sp>
+        <p:nvSpPr>
+          <p:cNvPr id="8" name="Title 1">
+            <a:extLst>
+              <a:ext uri="{FF2B5EF4-FFF2-40B4-BE49-F238E27FC236}">
+                <a16:creationId xmlns:a16="http://schemas.microsoft.com/office/drawing/2014/main" id="{99DB2A01-6CF8-F06A-6B9C-C685096E3E0C}"/>
+              </a:ext>
+            </a:extLst>
+          </p:cNvPr>
+          <p:cNvSpPr txBox="1"/>
+          <p:nvPr/>
+        </p:nvSpPr>
+        <p:spPr>
+          <a:xfrm>
+            <a:off x="1096092" y="1928724"/>
+            <a:ext cx="6888960" cy="3345597"/>
+          </a:xfrm>
+          <a:prstGeom prst="rect">
+            <a:avLst/>
+          </a:prstGeom>
+        </p:spPr>
+        <p:txBody>
+          <a:bodyPr vert="horz" lIns="91440" tIns="45720" rIns="91440" bIns="45720" rtlCol="0" anchor="t">
+            <a:noAutofit/>
+          </a:bodyPr>
+          <a:lstStyle>
+            <a:lvl1pPr algn="l" defTabSz="914400" rtl="0" eaLnBrk="1" latinLnBrk="0" hangingPunct="1">
+              <a:lnSpc>
+                <a:spcPct val="100000"/>
+              </a:lnSpc>
+              <a:spcBef>
+                <a:spcPct val="0"/>
+              </a:spcBef>
+              <a:buNone/>
+              <a:defRPr sz="4000" b="1" i="0" kern="1200">
+                <a:solidFill>
+                  <a:schemeClr val="tx1"/>
+                </a:solidFill>
+                <a:latin typeface="+mj-lt"/>
+                <a:ea typeface="+mj-ea"/>
+                <a:cs typeface="+mj-cs"/>
+              </a:defRPr>
+            </a:lvl1pPr>
+          </a:lstStyle>
+          <a:p>
+            <a:pPr marL="514350" indent="-514350">
+              <a:lnSpc>
+                <a:spcPct val="150000"/>
+              </a:lnSpc>
+              <a:buFont typeface="+mj-lt"/>
+              <a:buAutoNum type="arabicPeriod"/>
+            </a:pPr>
+            <a:endParaRPr lang="en-GB" sz="1600" b="0">
+              <a:latin typeface="Arial" panose="020B0604020202020204" pitchFamily="34" charset="0"/>
+              <a:cs typeface="Arial" panose="020B0604020202020204" pitchFamily="34" charset="0"/>
+            </a:endParaRPr>
+          </a:p>
+        </p:txBody>
+      </p:sp>
+      <p:pic>
+        <p:nvPicPr>
+          <p:cNvPr id="4" name="Picture 3" descr="A screenshot of a computer program&#10;&#10;AI-generated content may be incorrect.">
+            <a:extLst>
+              <a:ext uri="{FF2B5EF4-FFF2-40B4-BE49-F238E27FC236}">
+                <a16:creationId xmlns:a16="http://schemas.microsoft.com/office/drawing/2014/main" id="{0B602ED8-5D82-553A-0485-1C14AE24A1A7}"/>
+              </a:ext>
+            </a:extLst>
+          </p:cNvPr>
+          <p:cNvPicPr>
+            <a:picLocks noChangeAspect="1"/>
+          </p:cNvPicPr>
+          <p:nvPr/>
+        </p:nvPicPr>
+        <p:blipFill>
+          <a:blip r:embed="rId2"/>
+          <a:stretch>
+            <a:fillRect/>
+          </a:stretch>
+        </p:blipFill>
+        <p:spPr>
+          <a:xfrm>
+            <a:off x="2050382" y="1257551"/>
+            <a:ext cx="8422106" cy="4683793"/>
+          </a:xfrm>
+          <a:prstGeom prst="rect">
+            <a:avLst/>
+          </a:prstGeom>
+        </p:spPr>
+      </p:pic>
+    </p:spTree>
+    <p:extLst>
+      <p:ext uri="{BB962C8B-B14F-4D97-AF65-F5344CB8AC3E}">
+        <p14:creationId xmlns:p14="http://schemas.microsoft.com/office/powerpoint/2010/main" val="2208187676"/>
       </p:ext>
     </p:extLst>
   </p:cSld>

</xml_diff>